<commit_message>
links-26: aesthetic pass renders — ten sheets with the fuller cover, six decks without the footer footnotes, pack
From screenshots of every page of the Short Run sheet, both decks and the shortlist sheet:
the sheet's cover page ended a third of the way up, so its blocks are scaled up about 12%
and spaced (all ten sheets still eight pages); the ~7pt footnotes beside the footer on
colleague slides 5 and 7 and manager slides 4 and 6 — unreadable projected — are gone, their
sentence in the speaker notes; the manager summary tile's three-line label is two; the
fatigue slide's row label stays short with the 13-day caveat in the notes. deck-check: 153
rows agree. Pack rebuilt.

Co-Authored-By: Claude Fable 5.1 <noreply@anthropic.com>
Claude-Session: https://claude.ai/code/session_01MrfcTRinN39zgr6tpkue66
</commit_message>
<xml_diff>
--- a/docs/links-26/presentations/Even-Keel-for-colleagues.pptx
+++ b/docs/links-26/presentations/Even-Keel-for-colleagues.pptx
@@ -1396,7 +1396,7 @@
           <a:p>
             <a:r>
               <a:rPr lang="en-US" dirty="0"/>
-              <a:t>Basic pay follows the 35-hour week, which does not change; overtime and premium duties vary person to person. The Saturday and Sunday counts are the link’s fixed duties and leave out anything later given in a cover week. Saturdays in the contract are paid at time and a quarter, and on average a person is rostered about 28 a year instead of 26. Sundays stay overtime: 10 a week shared among 26 people instead of 8 among 20, so about the same each (20 a year, against 21). These are averages across the whole link — your own depends on which line you start on — and they are not a payslip; the Pay Calculator in the app does that.</a:t>
+              <a:t>Basic pay follows the 35-hour week, which does not change; overtime and premium duties vary person to person. The Saturday and Sunday counts are the link’s fixed duties and leave out anything later given in a cover week. Saturdays in the contract are paid at time and a quarter, and on average a person is rostered about 28 a year instead of 26. Sundays stay overtime: 10 a week shared among 26 people instead of 8 among 20, so about the same each (20 a year, against 21). These are averages across the whole link — your own depends on which line you start on — and they are not a payslip; the Pay Calculator in the app does that. The yearly figures are averages from the fixed rota; a cover week’s duties are not known yet and are left out.</a:t>
             </a:r>
             <a:endParaRPr lang="en-US" dirty="0"/>
           </a:p>
@@ -1572,7 +1572,7 @@
           <a:p>
             <a:r>
               <a:rPr lang="en-US" dirty="0"/>
-              <a:t>Be straight about this one. About five more a year each finish at 23:00 or later. Three of those come from the December rules — three on duty to the close every day, where today’s weekdays have two — and two from Even Keel’s Saturday, which has four to the close rather than three. Finishes at 22:00 or later go up more, from 78 to 94 a year: the rules also want five still on duty after 22:00, and two weekday lates finish at 22:30 with the ticket office. Early 06:20 starts hardly change. And because the shortest gap between two shifts is 14h 35m, nobody finishes late and starts early the next morning.</a:t>
+              <a:t>Be straight about this one. About five more a year each finish at 23:00 or later. Three of those come from the December rules — three on duty to the close every day, where today’s weekdays have two — and two from Even Keel’s Saturday, which has four to the close rather than three. Finishes at 22:00 or later go up more, from 78 to 94 a year: the rules also want five still on duty after 22:00, and two weekday lates finish at 22:30 with the ticket office. Early 06:20 starts hardly change. And because the shortest gap between two shifts is 14h 35m, nobody finishes late and starts early the next morning. The yearly figures are averages from the fixed rota; a cover week’s duties are not known yet and are left out.</a:t>
             </a:r>
             <a:endParaRPr lang="en-US" dirty="0"/>
           </a:p>
@@ -10806,45 +10806,6 @@
       </p:sp>
       <p:sp>
         <p:nvSpPr>
-          <p:cNvPr id="20" name="Text 18"/>
-          <p:cNvSpPr txBox="1"/>
-          <p:nvPr/>
-        </p:nvSpPr>
-        <p:spPr>
-          <a:xfrm>
-            <a:off x="4023360" y="4754880"/>
-            <a:ext cx="4663440" cy="310896"/>
-          </a:xfrm>
-          <a:prstGeom prst="rect">
-            <a:avLst/>
-          </a:prstGeom>
-          <a:noFill/>
-          <a:ln/>
-        </p:spPr>
-        <p:txBody>
-          <a:bodyPr wrap="square" lIns="0" tIns="0" rIns="0" bIns="0" rtlCol="0" anchor="t"/>
-          <a:lstStyle/>
-          <a:p>
-            <a:pPr algn="r" indent="0" marL="0">
-              <a:buNone/>
-            </a:pPr>
-            <a:r>
-              <a:rPr lang="en-US" sz="850" i="1" dirty="0">
-                <a:solidFill>
-                  <a:srgbClr val="5B6778"/>
-                </a:solidFill>
-                <a:latin typeface="Inter" pitchFamily="34" charset="0"/>
-                <a:ea typeface="Inter" pitchFamily="34" charset="-122"/>
-                <a:cs typeface="Inter" pitchFamily="34" charset="-120"/>
-              </a:rPr>
-              <a:t>Yearly figures are averages from the fixed rota; cover-week duties are not included.</a:t>
-            </a:r>
-            <a:endParaRPr lang="en-US" sz="850" dirty="0"/>
-          </a:p>
-        </p:txBody>
-      </p:sp>
-      <p:sp>
-        <p:nvSpPr>
           <p:cNvPr id="21" name="Text 19"/>
           <p:cNvSpPr txBox="1"/>
           <p:nvPr/>
@@ -12722,45 +12683,6 @@
               <a:t>More people stay on after 22:00 under the December staffing; five more a year after 23:00, four to the Saturday close.</a:t>
             </a:r>
             <a:endParaRPr lang="en-US" sz="1400" dirty="0"/>
-          </a:p>
-        </p:txBody>
-      </p:sp>
-      <p:sp>
-        <p:nvSpPr>
-          <p:cNvPr id="24" name="Text 22"/>
-          <p:cNvSpPr txBox="1"/>
-          <p:nvPr/>
-        </p:nvSpPr>
-        <p:spPr>
-          <a:xfrm>
-            <a:off x="4023360" y="4754880"/>
-            <a:ext cx="4663440" cy="310896"/>
-          </a:xfrm>
-          <a:prstGeom prst="rect">
-            <a:avLst/>
-          </a:prstGeom>
-          <a:noFill/>
-          <a:ln/>
-        </p:spPr>
-        <p:txBody>
-          <a:bodyPr wrap="square" lIns="0" tIns="0" rIns="0" bIns="0" rtlCol="0" anchor="t"/>
-          <a:lstStyle/>
-          <a:p>
-            <a:pPr algn="r" indent="0" marL="0">
-              <a:buNone/>
-            </a:pPr>
-            <a:r>
-              <a:rPr lang="en-US" sz="850" i="1" dirty="0">
-                <a:solidFill>
-                  <a:srgbClr val="5B6778"/>
-                </a:solidFill>
-                <a:latin typeface="Inter" pitchFamily="34" charset="0"/>
-                <a:ea typeface="Inter" pitchFamily="34" charset="-122"/>
-                <a:cs typeface="Inter" pitchFamily="34" charset="-120"/>
-              </a:rPr>
-              <a:t>Yearly figures are averages from the fixed rota; cover-week duties are not included.</a:t>
-            </a:r>
-            <a:endParaRPr lang="en-US" sz="850" dirty="0"/>
           </a:p>
         </p:txBody>
       </p:sp>

</xml_diff>